<commit_message>
new changes and enhanced UI
</commit_message>
<xml_diff>
--- a/CSAAS_Presentation.pptx
+++ b/CSAAS_Presentation.pptx
@@ -10975,8 +10975,8 @@
         </p:nvSpPr>
         <p:spPr>
           <a:xfrm>
-            <a:off x="347472" y="1005840"/>
-            <a:ext cx="3968496" cy="3063240"/>
+            <a:off x="347472" y="1005839"/>
+            <a:ext cx="3968496" cy="3999653"/>
           </a:xfrm>
           <a:prstGeom prst="rect">
             <a:avLst/>
@@ -11008,38 +11008,6 @@
       </p:sp>
       <p:sp>
         <p:nvSpPr>
-          <p:cNvPr id="4" name="Shape 2"/>
-          <p:cNvSpPr/>
-          <p:nvPr/>
-        </p:nvSpPr>
-        <p:spPr>
-          <a:xfrm>
-            <a:off x="484632" y="1170432"/>
-            <a:ext cx="3694176" cy="2404872"/>
-          </a:xfrm>
-          <a:prstGeom prst="rect">
-            <a:avLst/>
-          </a:prstGeom>
-          <a:solidFill>
-            <a:srgbClr val="D6EAF2"/>
-          </a:solidFill>
-          <a:ln w="12700">
-            <a:solidFill>
-              <a:srgbClr val="E2E8F0"/>
-            </a:solidFill>
-            <a:prstDash val="solid"/>
-          </a:ln>
-        </p:spPr>
-        <p:txBody>
-          <a:bodyPr/>
-          <a:lstStyle/>
-          <a:p>
-            <a:endParaRPr lang="en-IN"/>
-          </a:p>
-        </p:txBody>
-      </p:sp>
-      <p:sp>
-        <p:nvSpPr>
           <p:cNvPr id="5" name="Text 3"/>
           <p:cNvSpPr/>
           <p:nvPr/>
@@ -11118,7 +11086,7 @@
         </p:nvSpPr>
         <p:spPr>
           <a:xfrm>
-            <a:off x="347472" y="3666744"/>
+            <a:off x="347472" y="4706111"/>
             <a:ext cx="3968496" cy="347472"/>
           </a:xfrm>
           <a:prstGeom prst="rect">
@@ -11398,7 +11366,37 @@
         <p:spPr>
           <a:xfrm>
             <a:off x="457200" y="1124712"/>
-            <a:ext cx="3769360" cy="2440749"/>
+            <a:ext cx="3769360" cy="1924301"/>
+          </a:xfrm>
+          <a:prstGeom prst="rect">
+            <a:avLst/>
+          </a:prstGeom>
+        </p:spPr>
+      </p:pic>
+      <p:pic>
+        <p:nvPicPr>
+          <p:cNvPr id="14" name="Picture 13">
+            <a:extLst>
+              <a:ext uri="{FF2B5EF4-FFF2-40B4-BE49-F238E27FC236}">
+                <a16:creationId xmlns:a16="http://schemas.microsoft.com/office/drawing/2014/main" id="{BD12BF45-3230-1057-B31A-C35FA71F9B59}"/>
+              </a:ext>
+            </a:extLst>
+          </p:cNvPr>
+          <p:cNvPicPr>
+            <a:picLocks noChangeAspect="1"/>
+          </p:cNvPicPr>
+          <p:nvPr/>
+        </p:nvPicPr>
+        <p:blipFill>
+          <a:blip r:embed="rId4"/>
+          <a:stretch>
+            <a:fillRect/>
+          </a:stretch>
+        </p:blipFill>
+        <p:spPr>
+          <a:xfrm>
+            <a:off x="457200" y="3167884"/>
+            <a:ext cx="3769360" cy="1503344"/>
           </a:xfrm>
           <a:prstGeom prst="rect">
             <a:avLst/>

</xml_diff>